<commit_message>
docs: describe single-action step and journal actions, drop clause counter
</commit_message>
<xml_diff>
--- a/docs/presentation/Презентация_ЛР3_Минязов.pptx
+++ b/docs/presentation/Презентация_ЛР3_Минязов.pptx
@@ -943,7 +943,7 @@
           <a:p>
             <a:r>
               <a:rPr lang="en-US" dirty="0"/>
-              <a:t>Живая демонстрация: «Пример из задания», три раза «Шаг» — журнал как в задании. Снять «показывать правду» — видно, что охотник карту не видит. «Новая пещера» с ошибками — окно подсвечивает поля и не закрывается.</a:t>
+              <a:t>Живая демонстрация: «Пример из задания», нажимать «Шаг» — охотник поворачивается и ходит по одному действию, журнал пополняется в каждой новой комнате, как в задании. Снять «показывать правду» — видно, что охотник карту не видит. «Новая пещера» с ошибками — окно подсвечивает поля и не закрывается.</a:t>
             </a:r>
             <a:endParaRPr lang="en-US" dirty="0"/>
           </a:p>
@@ -3234,7 +3234,7 @@
                 <a:ea typeface="Calibri" pitchFamily="34" charset="-122"/>
                 <a:cs typeface="Calibri" pitchFamily="34" charset="-120"/>
               </a:rPr>
-              <a:t>пять пакетов; шесть видов UML; 169 автотестов</a:t>
+              <a:t>пять пакетов; шесть видов UML; 171 автотест</a:t>
             </a:r>
             <a:endParaRPr lang="en-US" sz="1800" dirty="0"/>
           </a:p>
@@ -8963,8 +8963,8 @@
         </p:blipFill>
         <p:spPr>
           <a:xfrm>
-            <a:off x="1296380" y="4224528"/>
-            <a:ext cx="1979240" cy="1645920"/>
+            <a:off x="1268065" y="4224528"/>
+            <a:ext cx="2035869" cy="1645920"/>
           </a:xfrm>
           <a:prstGeom prst="rect">
             <a:avLst/>

</xml_diff>